<commit_message>
feat: robots.txt/sitemap 점검 항목 추가 (메인 홈), 점검결과 403 반영
- robots.txt 실측: www·m.hanwhadirect.com/robots.txt 모두 HTTP 403(봇 차단)
- 홈(메인 m.hanwhadirect.com) To-Do에 robots.txt·sitemap 설치/점검 추가(우선순위 상)
  · Yeti·Googlebot 명시 허용 + Sitemap 등록 권장본 제공
- 기존 홈 JSON-LD 항목은 robots로 대체(순수 파일/HTML 위주)
- Excel/PPT 태깅가이드도 동일 반영

Co-Authored-By: Claude Opus 4.8 <noreply@anthropic.com>
Claude-Session: https://claude.ai/code/session_01GhxZYksEXdBzqoiFpg6L1A
</commit_message>
<xml_diff>
--- a/handoff/한화손보_장기CM_태깅가이드.pptx
+++ b/handoff/한화손보_장기CM_태깅가이드.pptx
@@ -7871,13 +7871,13 @@
                           </a:solidFill>
                           <a:latin typeface="Arial"/>
                         </a:rPr>
-                        <a:t>중</a:t>
-                      </a:r>
-                    </a:p>
-                  </a:txBody>
-                  <a:tcPr marT="25400" marB="25400" anchor="ctr">
-                    <a:solidFill>
-                      <a:srgbClr val="C47F12"/>
+                        <a:t>상</a:t>
+                      </a:r>
+                    </a:p>
+                  </a:txBody>
+                  <a:tcPr marT="25400" marB="25400" anchor="ctr">
+                    <a:solidFill>
+                      <a:srgbClr val="E5484D"/>
                     </a:solidFill>
                   </a:tcPr>
                 </a:tc>
@@ -7893,7 +7893,7 @@
                           </a:solidFill>
                           <a:latin typeface="Arial"/>
                         </a:rPr>
-                        <a:t>OG 태그 세트 추가/점검</a:t>
+                        <a:t>robots.txt · sitemap.xml 설치/점검 (사이트 전체)</a:t>
                       </a:r>
                     </a:p>
                   </a:txBody>
@@ -7915,7 +7915,7 @@
                           </a:solidFill>
                           <a:latin typeface="Consolas"/>
                         </a:rPr>
-                        <a:t>&lt;meta property="og:title" content="한화손보다이렉트 — 필요한 보험을 한 곳에서"&gt;</a:t>
+                        <a:t># robots.txt (사이트 루트)</a:t>
                       </a:r>
                     </a:p>
                     <a:p>
@@ -7926,7 +7926,7 @@
                           </a:solidFill>
                           <a:latin typeface="Consolas"/>
                         </a:rPr>
-                        <a:t>&lt;meta property="og:description" content="장기보험을 개인정보 없이 3분 만에 비교하고 보험료를 확인해요."&gt;</a:t>
+                        <a:t>User-agent: Yeti</a:t>
                       </a:r>
                     </a:p>
                     <a:p>
@@ -7937,7 +7937,7 @@
                           </a:solidFill>
                           <a:latin typeface="Consolas"/>
                         </a:rPr>
-                        <a:t>&lt;meta property="og:image" content="https://.../og/home_1200x630.png"&gt;</a:t>
+                        <a:t>Allow: /</a:t>
                       </a:r>
                     </a:p>
                     <a:p>
@@ -7948,7 +7948,51 @@
                           </a:solidFill>
                           <a:latin typeface="Consolas"/>
                         </a:rPr>
-                        <a:t>&lt;meta property="og:url" content="https://m.hanwhadirect.com/"&gt;</a:t>
+                        <a:t>User-agent: Googlebot</a:t>
+                      </a:r>
+                    </a:p>
+                    <a:p>
+                      <a:r>
+                        <a:rPr sz="800">
+                          <a:solidFill>
+                            <a:srgbClr val="2B2B40"/>
+                          </a:solidFill>
+                          <a:latin typeface="Consolas"/>
+                        </a:rPr>
+                        <a:t>Allow: /</a:t>
+                      </a:r>
+                    </a:p>
+                    <a:p>
+                      <a:r>
+                        <a:rPr sz="800">
+                          <a:solidFill>
+                            <a:srgbClr val="2B2B40"/>
+                          </a:solidFill>
+                          <a:latin typeface="Consolas"/>
+                        </a:rPr>
+                        <a:t>User-agent: *</a:t>
+                      </a:r>
+                    </a:p>
+                    <a:p>
+                      <a:r>
+                        <a:rPr sz="800">
+                          <a:solidFill>
+                            <a:srgbClr val="2B2B40"/>
+                          </a:solidFill>
+                          <a:latin typeface="Consolas"/>
+                        </a:rPr>
+                        <a:t>Allow: /</a:t>
+                      </a:r>
+                    </a:p>
+                    <a:p>
+                      <a:r>
+                        <a:rPr sz="800">
+                          <a:solidFill>
+                            <a:srgbClr val="2B2B40"/>
+                          </a:solidFill>
+                          <a:latin typeface="Consolas"/>
+                        </a:rPr>
+                        <a:t>Sitemap: https://www.hanwhadirect.com/sitemap.xml</a:t>
                       </a:r>
                     </a:p>
                   </a:txBody>
@@ -7995,7 +8039,7 @@
                           </a:solidFill>
                           <a:latin typeface="Arial"/>
                         </a:rPr>
-                        <a:t>모바일(m.)·PC(www) 메타 일치 + canonical</a:t>
+                        <a:t>OG 태그 세트 추가/점검</a:t>
                       </a:r>
                     </a:p>
                   </a:txBody>
@@ -8017,7 +8061,7 @@
                           </a:solidFill>
                           <a:latin typeface="Consolas"/>
                         </a:rPr>
-                        <a:t>&lt;link rel="canonical" href="https://www.hanwhadirect.com/"&gt;</a:t>
+                        <a:t>&lt;meta property="og:title" content="한화손보다이렉트 — 필요한 보험을 한 곳에서"&gt;</a:t>
                       </a:r>
                     </a:p>
                     <a:p>
@@ -8028,7 +8072,29 @@
                           </a:solidFill>
                           <a:latin typeface="Consolas"/>
                         </a:rPr>
-                        <a:t>&lt;link rel="alternate" media="only screen and (max-width: 640px)" href="https://m.hanwhadirect.com/"&gt;</a:t>
+                        <a:t>&lt;meta property="og:description" content="장기보험을 개인정보 없이 3분 만에 비교하고 보험료를 확인해요."&gt;</a:t>
+                      </a:r>
+                    </a:p>
+                    <a:p>
+                      <a:r>
+                        <a:rPr sz="800">
+                          <a:solidFill>
+                            <a:srgbClr val="2B2B40"/>
+                          </a:solidFill>
+                          <a:latin typeface="Consolas"/>
+                        </a:rPr>
+                        <a:t>&lt;meta property="og:image" content="https://.../og/home_1200x630.png"&gt;</a:t>
+                      </a:r>
+                    </a:p>
+                    <a:p>
+                      <a:r>
+                        <a:rPr sz="800">
+                          <a:solidFill>
+                            <a:srgbClr val="2B2B40"/>
+                          </a:solidFill>
+                          <a:latin typeface="Consolas"/>
+                        </a:rPr>
+                        <a:t>&lt;meta property="og:url" content="https://m.hanwhadirect.com/"&gt;</a:t>
                       </a:r>
                     </a:p>
                   </a:txBody>
@@ -8075,7 +8141,7 @@
                           </a:solidFill>
                           <a:latin typeface="Arial"/>
                         </a:rPr>
-                        <a:t>사이트명·브랜드 구조화(WebSite/Organization)</a:t>
+                        <a:t>모바일(m.)·PC(www) 메타 일치 + canonical</a:t>
                       </a:r>
                     </a:p>
                   </a:txBody>
@@ -8097,7 +8163,18 @@
                           </a:solidFill>
                           <a:latin typeface="Consolas"/>
                         </a:rPr>
-                        <a:t>&lt;script type="application/ld+json"&gt;{"@context":"https://schema.org","@type":"WebSite","name":"한화손해보험 다이렉트","url":"https://www.hanwhadirect.com/"}&lt;/script&gt;</a:t>
+                        <a:t>&lt;link rel="canonical" href="https://www.hanwhadirect.com/"&gt;</a:t>
+                      </a:r>
+                    </a:p>
+                    <a:p>
+                      <a:r>
+                        <a:rPr sz="800">
+                          <a:solidFill>
+                            <a:srgbClr val="2B2B40"/>
+                          </a:solidFill>
+                          <a:latin typeface="Consolas"/>
+                        </a:rPr>
+                        <a:t>&lt;link rel="alternate" media="only screen and (max-width: 640px)" href="https://m.hanwhadirect.com/"&gt;</a:t>
                       </a:r>
                     </a:p>
                   </a:txBody>

</xml_diff>

<commit_message>
feat: 완성 robots.txt (/cmcom/·관리자·검색결과 Disallow)
- handoff/robots.txt 완성본 추가: Yeti·Googlebot·Daumoa 허용 + 사이트맵 2종
  Disallow /cmcom/(브릿지)·/admin//manager//mng/(관리자)·/search·검색 파라미터
- 툴 robots To-Do·Excel/PPT 태깅가이드도 동일 규칙 반영
- /cmcom/ 301 리다이렉트 케이스 caveat 주석 포함

Co-Authored-By: Claude Opus 4.8 <noreply@anthropic.com>
Claude-Session: https://claude.ai/code/session_01GhxZYksEXdBzqoiFpg6L1A
</commit_message>
<xml_diff>
--- a/handoff/한화손보_장기CM_태깅가이드.pptx
+++ b/handoff/한화손보_장기CM_태깅가이드.pptx
@@ -7982,6 +7982,94 @@
                           <a:latin typeface="Consolas"/>
                         </a:rPr>
                         <a:t>Allow: /</a:t>
+                      </a:r>
+                    </a:p>
+                    <a:p>
+                      <a:r>
+                        <a:rPr sz="800">
+                          <a:solidFill>
+                            <a:srgbClr val="2B2B40"/>
+                          </a:solidFill>
+                          <a:latin typeface="Consolas"/>
+                        </a:rPr>
+                        <a:t>Disallow: /cmcom/</a:t>
+                      </a:r>
+                    </a:p>
+                    <a:p>
+                      <a:r>
+                        <a:rPr sz="800">
+                          <a:solidFill>
+                            <a:srgbClr val="2B2B40"/>
+                          </a:solidFill>
+                          <a:latin typeface="Consolas"/>
+                        </a:rPr>
+                        <a:t>Disallow: /admin/</a:t>
+                      </a:r>
+                    </a:p>
+                    <a:p>
+                      <a:r>
+                        <a:rPr sz="800">
+                          <a:solidFill>
+                            <a:srgbClr val="2B2B40"/>
+                          </a:solidFill>
+                          <a:latin typeface="Consolas"/>
+                        </a:rPr>
+                        <a:t>Disallow: /manager/</a:t>
+                      </a:r>
+                    </a:p>
+                    <a:p>
+                      <a:r>
+                        <a:rPr sz="800">
+                          <a:solidFill>
+                            <a:srgbClr val="2B2B40"/>
+                          </a:solidFill>
+                          <a:latin typeface="Consolas"/>
+                        </a:rPr>
+                        <a:t>Disallow: /mng/</a:t>
+                      </a:r>
+                    </a:p>
+                    <a:p>
+                      <a:r>
+                        <a:rPr sz="800">
+                          <a:solidFill>
+                            <a:srgbClr val="2B2B40"/>
+                          </a:solidFill>
+                          <a:latin typeface="Consolas"/>
+                        </a:rPr>
+                        <a:t>Disallow: /search</a:t>
+                      </a:r>
+                    </a:p>
+                    <a:p>
+                      <a:r>
+                        <a:rPr sz="800">
+                          <a:solidFill>
+                            <a:srgbClr val="2B2B40"/>
+                          </a:solidFill>
+                          <a:latin typeface="Consolas"/>
+                        </a:rPr>
+                        <a:t>Disallow: /*?keyword=</a:t>
+                      </a:r>
+                    </a:p>
+                    <a:p>
+                      <a:r>
+                        <a:rPr sz="800">
+                          <a:solidFill>
+                            <a:srgbClr val="2B2B40"/>
+                          </a:solidFill>
+                          <a:latin typeface="Consolas"/>
+                        </a:rPr>
+                        <a:t>Disallow: /*?q=</a:t>
+                      </a:r>
+                    </a:p>
+                    <a:p>
+                      <a:r>
+                        <a:rPr sz="800">
+                          <a:solidFill>
+                            <a:srgbClr val="2B2B40"/>
+                          </a:solidFill>
+                          <a:latin typeface="Consolas"/>
+                        </a:rPr>
+                        <a:t>Sitemap: https://m.hanwhadirect.com/sitemap.xml</a:t>
                       </a:r>
                     </a:p>
                     <a:p>

</xml_diff>